<commit_message>
feat: complete comprehensive review revisions across model, deck, memo, hub and landing page
</commit_message>
<xml_diff>
--- a/deliverables/BrightCHAMPS_USA_Q4_Strategy_Deck.pptx
+++ b/deliverables/BrightCHAMPS_USA_Q4_Strategy_Deck.pptx
@@ -3208,7 +3208,7 @@
               </a:defRPr>
             </a:pPr>
             <a:r>
-              <a:t>A Dual-Pillar Framework Combining Mutually Exclusive Geo-Targeting with Monotonic Meta CAPI &amp; Instant Calendar Booking</a:t>
+              <a:t>A Dual-Pillar Framework Combining Mutually Exclusive Geo-Targeting with Monotonic Meta CAPI v21.0 &amp; Instant Intake</a:t>
             </a:r>
           </a:p>
           <a:p>
@@ -3220,7 +3220,7 @@
               </a:defRPr>
             </a:pPr>
             <a:r>
-              <a:t>Stakeholder: Yatharth Sahoo (Senior Lead, Founder's Office) | Author: Bharanee B (AI Associate, Founder's Office)</a:t>
+              <a:t>Stakeholder: Yatharth Sahoo (Senior Lead, Founder's Office) | Author: Bharanee B (AI Associate, Founder's Office | +91 7708221675)</a:t>
             </a:r>
           </a:p>
         </p:txBody>
@@ -3308,7 +3308,7 @@
               </a:defRPr>
             </a:pPr>
             <a:r>
-              <a:t>8. Legal Compliance Architecture &amp; Assumptions Register</a:t>
+              <a:t>8. Legal Compliance &amp; Strategic Pushbacks Appendix</a:t>
             </a:r>
           </a:p>
         </p:txBody>
@@ -3406,7 +3406,7 @@
                   <a:srgbClr val="1E1B4B"/>
                 </a:solidFill>
               </a:rPr>
-              <a:t>TCPA (Telephone Consumer Protection Act): </a:t>
+              <a:t>TCPA Compliance: </a:t>
             </a:r>
             <a:r>
               <a:rPr b="0" i="0" sz="850">
@@ -3414,7 +3414,7 @@
                   <a:srgbClr val="0F172A"/>
                 </a:solidFill>
               </a:rPr>
-              <a:t>Mandatory explicit consent checkbox on Step 2. Clear disclosure that purchase is not conditional on consent, with one-click opt-out ('STOP').</a:t>
+              <a:t>Mandatory explicit consent checkbox on Step 2. Disclosure stating consent is not required for purchase, with one-click opt-out ('STOP').</a:t>
             </a:r>
           </a:p>
           <a:p>
@@ -3429,7 +3429,7 @@
                   <a:srgbClr val="1E1B4B"/>
                 </a:solidFill>
               </a:rPr>
-              <a:t>COPPA (Children's Online Privacy Protection): </a:t>
+              <a:t>COPPA Compliance: </a:t>
             </a:r>
             <a:r>
               <a:rPr b="0" i="0" sz="850">
@@ -3437,7 +3437,7 @@
                   <a:srgbClr val="0F172A"/>
                 </a:solidFill>
               </a:rPr>
-              <a:t>Strict parent-facing intake gate. Zero child PII (name, age, grade) transmitted to Meta CAPI or ad networks; only SHA-256 hashed parent contact records.</a:t>
+              <a:t>Strict parent-facing intake gate with guardian attestation. Zero child PII (name, age, grade) sent to Meta CAPI; only SHA-256 hashed parent records.</a:t>
             </a:r>
           </a:p>
           <a:p>
@@ -3452,7 +3452,7 @@
                   <a:srgbClr val="1E1B4B"/>
                 </a:solidFill>
               </a:rPr>
-              <a:t>Meta Minor Advertising Guidelines: </a:t>
+              <a:t>Meta Minor Guidelines: </a:t>
             </a:r>
             <a:r>
               <a:rPr b="0" i="0" sz="850">
@@ -3460,7 +3460,7 @@
                   <a:srgbClr val="0F172A"/>
                 </a:solidFill>
               </a:rPr>
-              <a:t>Ad targeting configured strictly for Parents Age 30-55. Creative messaging emphasizes parental co-learning and academic enrichment.</a:t>
+              <a:t>Ad targeting strictly on Parents Age 30-55. Creative emphasizes parental co-learning and academic enrichment.</a:t>
             </a:r>
           </a:p>
         </p:txBody>
@@ -3534,7 +3534,7 @@
           <a:p>
             <a:pPr>
               <a:spcAft>
-                <a:spcPts val="800"/>
+                <a:spcPts val="600"/>
               </a:spcAft>
               <a:defRPr sz="1000" b="1">
                 <a:solidFill>
@@ -3543,99 +3543,99 @@
               </a:defRPr>
             </a:pPr>
             <a:r>
-              <a:t>ASSUMPTIONS REGISTER &amp; VALIDATION TESTS</a:t>
+              <a:t>STRATEGIC PUSHBACKS &amp; DEFENSES</a:t>
             </a:r>
           </a:p>
           <a:p>
             <a:pPr>
               <a:spcAft>
-                <a:spcPts val="600"/>
+                <a:spcPts val="400"/>
               </a:spcAft>
             </a:pPr>
             <a:r>
-              <a:rPr b="1" i="0" sz="850">
+              <a:rPr b="1" i="0" sz="800">
                 <a:solidFill>
                   <a:srgbClr val="1E1B4B"/>
                 </a:solidFill>
               </a:rPr>
-              <a:t>Blended CPL $29.85: </a:t>
-            </a:r>
-            <a:r>
-              <a:rPr b="0" i="0" sz="850">
+              <a:t>1. At $36 CPL, is margin wiped out? </a:t>
+            </a:r>
+            <a:r>
+              <a:rPr b="0" i="0" sz="800">
                 <a:solidFill>
                   <a:srgbClr val="0F172A"/>
                 </a:solidFill>
               </a:rPr>
-              <a:t>High confidence | Source: Q3 US Meta benchmark | Validating Test: Day 1-3 pilot at $2.5k/day in Dallas &amp; Bay Area.</a:t>
+              <a:t>Blended break-even CPL is $36.76, while Tier 1 delivers $850 Net ARPU and 2.85x ROAS (22% close). Tier 1 CPL is capped at $42, managed via cost/attended demo ($62.12 target).</a:t>
             </a:r>
           </a:p>
           <a:p>
             <a:pPr>
               <a:spcAft>
-                <a:spcPts val="600"/>
+                <a:spcPts val="400"/>
               </a:spcAft>
             </a:pPr>
             <a:r>
-              <a:rPr b="1" i="0" sz="850">
+              <a:rPr b="1" i="0" sz="800">
                 <a:solidFill>
                   <a:srgbClr val="1E1B4B"/>
                 </a:solidFill>
               </a:rPr>
-              <a:t>Demo Show Rate 71%: </a:t>
-            </a:r>
-            <a:r>
-              <a:rPr b="0" i="0" sz="850">
+              <a:t>2. Why 71% show rate vs Round 1 64.8%? </a:t>
+            </a:r>
+            <a:r>
+              <a:rPr b="0" i="0" sz="800">
                 <a:solidFill>
                   <a:srgbClr val="0F172A"/>
                 </a:solidFill>
               </a:rPr>
-              <a:t>High confidence | Source: Instant calendar lock + reminder cadence | Validating Test: First 100 scheduled slots Nov 1-4.</a:t>
+              <a:t>Demos within 24-48h showed 74-78% in R1 (correlational). Even at 64.8%, contribution is positive at +$20,386, and our 62% floor triggers phone confirmation gates.</a:t>
             </a:r>
           </a:p>
           <a:p>
             <a:pPr>
               <a:spcAft>
-                <a:spcPts val="600"/>
+                <a:spcPts val="400"/>
               </a:spcAft>
             </a:pPr>
             <a:r>
-              <a:rPr b="1" i="0" sz="850">
+              <a:rPr b="1" i="0" sz="800">
                 <a:solidFill>
                   <a:srgbClr val="1E1B4B"/>
                 </a:solidFill>
               </a:rPr>
-              <a:t>Demo Close Rate 17.9%: </a:t>
-            </a:r>
-            <a:r>
-              <a:rPr b="0" i="0" sz="850">
+              <a:t>3. What is LTV and renewal rate? </a:t>
+            </a:r>
+            <a:r>
+              <a:rPr b="0" i="0" sz="800">
                 <a:solidFill>
                   <a:srgbClr val="0F172A"/>
                 </a:solidFill>
               </a:rPr>
-              <a:t>Medium confidence | Source: Senior US sales counselor pod | Validating Test: First 25 completed sessions.</a:t>
+              <a:t>On a GM basis, first-order LTV/CAC is 1.23x ($777 net ARPU x 55% GM / $347 CAC). Conservative model excludes renewals; US cohort data will refine lifetime value.</a:t>
             </a:r>
           </a:p>
           <a:p>
             <a:pPr>
               <a:spcAft>
-                <a:spcPts val="600"/>
+                <a:spcPts val="400"/>
               </a:spcAft>
             </a:pPr>
             <a:r>
-              <a:rPr b="1" i="0" sz="850">
+              <a:rPr b="1" i="0" sz="800">
                 <a:solidFill>
                   <a:srgbClr val="1E1B4B"/>
                 </a:solidFill>
               </a:rPr>
-              <a:t>Gross Margin 55%: </a:t>
-            </a:r>
-            <a:r>
-              <a:rPr b="0" i="0" sz="850">
+              <a:t>4. Meta removed ethnicity; why not broad? </a:t>
+            </a:r>
+            <a:r>
+              <a:rPr b="0" i="0" sz="800">
                 <a:solidFill>
                   <a:srgbClr val="0F172A"/>
                 </a:solidFill>
               </a:rPr>
-              <a:t>High confidence | Source: Mentor payout ($30-35/hr) + SaaS COGS | Validating Test: Unit cost ledger audit.</a:t>
+              <a:t>We agree direct ethnic targeting is impossible. A 10-15% broad Advantage+ control arm will empirically test if tiers beat the algorithm on cost per attended demo.</a:t>
             </a:r>
           </a:p>
         </p:txBody>
@@ -3829,7 +3829,7 @@
                   <a:srgbClr val="0F172A"/>
                 </a:solidFill>
               </a:rPr>
-              <a:t>Pilot spend ($2.5k/day) in Bay Area &amp; Dallas. Verify CAPI EMQ &gt; 8.0 and slot sync.</a:t>
+              <a:t>Pilot spend ($2.5k/day) in Bay Area &amp; Dallas. Verify CAPI EMQ &gt; 8.0, raw pass rate (target 80% @ raw CPL &lt;= $23.88), and slot sync.</a:t>
             </a:r>
           </a:p>
           <a:p>
@@ -3844,7 +3844,7 @@
                   <a:srgbClr val="1E1B4B"/>
                 </a:solidFill>
               </a:rPr>
-              <a:t>Days 4-7 (Hook Calibration): </a:t>
+              <a:t>Days 4-7 (Hook &amp; Voucher A/B): </a:t>
             </a:r>
             <a:r>
               <a:rPr b="0" i="0" sz="850">
@@ -3852,7 +3852,7 @@
                   <a:srgbClr val="0F172A"/>
                 </a:solidFill>
               </a:rPr>
-              <a:t>A/B test 'Beyond Kumon' vs. 'Academic Logic Edge'. Calibrate ad-set CPMs.</a:t>
+              <a:t>A/B test 'Beyond Kumon' vs. 'Academic Edge' and $150 voucher vs control. Calibrate ad-set CPMs.</a:t>
             </a:r>
           </a:p>
           <a:p>
@@ -3875,7 +3875,7 @@
                   <a:srgbClr val="0F172A"/>
                 </a:solidFill>
               </a:rPr>
-              <a:t>First 200+ completed demos. Audit show rate and initial Stripe transactions.</a:t>
+              <a:t>First 200+ completed demos. Audit show rate, cost per attended demo against $62.12 target, and initial Stripe transactions.</a:t>
             </a:r>
           </a:p>
           <a:p>
@@ -3899,9 +3899,9 @@
                 </a:solidFill>
               </a:rPr>
               <a:t>
-• Trigger 1: If Tier 1 CPL &gt; $42 after 150 leads -&gt; Shift 10% budget to Tier 2.
+• Trigger 1: If Tier 1 CPL &gt; $42 after 150 leads -&gt; Shift 50% budget to Tier 2.
 • Trigger 2: If Booking Rate &lt; 55% -&gt; Activate fallback 1-step sticky form.
-• Trigger 3: If Show Rate &lt; 60% -&gt; Mandate manual phone check-in at T-4h.</a:t>
+• Trigger 3: If Show Rate &lt; 62% -&gt; Mandate manual phone check-in at T-2h.</a:t>
             </a:r>
           </a:p>
         </p:txBody>
@@ -4007,7 +4007,7 @@
                   <a:srgbClr val="0F172A"/>
                 </a:solidFill>
               </a:rPr>
-              <a:t>Verified with SHA-256 parent hashing &amp; monotonic event values.</a:t>
+              <a:t>Verified with SHA-256 parent hashing &amp; monotonic event values (v21.0).</a:t>
             </a:r>
           </a:p>
           <a:p>
@@ -4030,7 +4030,7 @@
                   <a:srgbClr val="0F172A"/>
                 </a:solidFill>
               </a:rPr>
-              <a:t>Uploaded to Meta Business Manager.</a:t>
+              <a:t>Uploaded to Meta Business Manager with Advantage+ control arm.</a:t>
             </a:r>
           </a:p>
           <a:p>
@@ -4053,7 +4053,7 @@
                   <a:srgbClr val="0F172A"/>
                 </a:solidFill>
               </a:rPr>
-              <a:t>Laptop access question, SMS OTP mock &amp; TCPA consent live.</a:t>
+              <a:t>Laptop access question, SMS OTP mock, guardian attestation &amp; TCPA live.</a:t>
             </a:r>
           </a:p>
           <a:p>
@@ -4076,7 +4076,7 @@
                   <a:srgbClr val="0F172A"/>
                 </a:solidFill>
               </a:rPr>
-              <a:t>Configured on 'Schedule' with 'Purchase' as value signal.</a:t>
+              <a:t>Configured on 'Schedule' with 'Purchase' as offline value signal.</a:t>
             </a:r>
           </a:p>
           <a:p>
@@ -4099,7 +4099,7 @@
                   <a:srgbClr val="0F172A"/>
                 </a:solidFill>
               </a:rPr>
-              <a:t>Authorize $164,175 media pacing across Nov-Dec.</a:t>
+              <a:t>Authorize $164,175 media pacing ($77k Nov / $87.2k Dec).</a:t>
             </a:r>
           </a:p>
           <a:p>
@@ -4122,7 +4122,7 @@
                   <a:srgbClr val="0F172A"/>
                 </a:solidFill>
               </a:rPr>
-              <a:t>Confirm roster of 16 dedicated US-shift mentors.</a:t>
+              <a:t>Confirm roster of 16 dedicated US-shift mentors + 6 flex pool.</a:t>
             </a:r>
           </a:p>
           <a:p>
@@ -4145,7 +4145,7 @@
                   <a:srgbClr val="0F172A"/>
                 </a:solidFill>
               </a:rPr>
-              <a:t>Approve $150 tuition scholarship voucher for BFCM.</a:t>
+              <a:t>Approve $150 tuition voucher A/B test for BFCM.</a:t>
             </a:r>
           </a:p>
         </p:txBody>
@@ -4307,7 +4307,7 @@
           <a:p>
             <a:pPr>
               <a:spcAft>
-                <a:spcPts val="1000"/>
+                <a:spcPts val="800"/>
               </a:spcAft>
               <a:defRPr sz="1100" b="1">
                 <a:solidFill>
@@ -4322,34 +4322,34 @@
           <a:p>
             <a:pPr>
               <a:spcAft>
-                <a:spcPts val="400"/>
+                <a:spcPts val="300"/>
               </a:spcAft>
             </a:pPr>
             <a:r>
-              <a:rPr b="1" i="0" sz="950">
+              <a:rPr b="1" i="0" sz="900">
                 <a:solidFill>
                   <a:srgbClr val="1E1B4B"/>
                 </a:solidFill>
               </a:rPr>
-              <a:t>Inbound Leads: </a:t>
-            </a:r>
-            <a:r>
-              <a:rPr b="0" i="0" sz="950">
+              <a:t>Qualified Leads: </a:t>
+            </a:r>
+            <a:r>
+              <a:rPr b="0" i="0" sz="900">
                 <a:solidFill>
                   <a:srgbClr val="0F172A"/>
                 </a:solidFill>
               </a:rPr>
-              <a:t>5,500 Leads (Nov: 2,500 | Dec: 3,000)</a:t>
+              <a:t>5,500 Qualified Leads (Nov: 2,500 | Dec: 3,000)</a:t>
             </a:r>
           </a:p>
           <a:p>
             <a:pPr>
               <a:spcAft>
-                <a:spcPts val="400"/>
+                <a:spcPts val="300"/>
               </a:spcAft>
             </a:pPr>
             <a:r>
-              <a:rPr b="1" i="0" sz="950">
+              <a:rPr b="1" i="0" sz="900">
                 <a:solidFill>
                   <a:srgbClr val="1E1B4B"/>
                 </a:solidFill>
@@ -4357,114 +4357,114 @@
               <a:t>Blended CPL: </a:t>
             </a:r>
             <a:r>
-              <a:rPr b="0" i="0" sz="950">
+              <a:rPr b="0" i="0" sz="900">
                 <a:solidFill>
                   <a:srgbClr val="0F172A"/>
                 </a:solidFill>
               </a:rPr>
-              <a:t>$29.85 USD (Under $30.00 ceiling by -$0.15 buffer)</a:t>
+              <a:t>$29.85 USD (Spend: $164,175.00 vs $165,000 budget cap; $825 buffer)</a:t>
             </a:r>
           </a:p>
           <a:p>
             <a:pPr>
               <a:spcAft>
-                <a:spcPts val="400"/>
+                <a:spcPts val="300"/>
               </a:spcAft>
             </a:pPr>
             <a:r>
-              <a:rPr b="1" i="0" sz="950">
+              <a:rPr b="1" i="0" sz="900">
                 <a:solidFill>
                   <a:srgbClr val="1E1B4B"/>
                 </a:solidFill>
               </a:rPr>
-              <a:t>Total Media Spend: </a:t>
-            </a:r>
-            <a:r>
-              <a:rPr b="0" i="0" sz="950">
+              <a:t>Funnel Throughput: </a:t>
+            </a:r>
+            <a:r>
+              <a:rPr b="0" i="0" sz="900">
                 <a:solidFill>
                   <a:srgbClr val="0F172A"/>
                 </a:solidFill>
               </a:rPr>
-              <a:t>$164,175.00 USD (Under $165,000.00 ceiling by -$825.00)</a:t>
+              <a:t>3,723 Demos Booked (67.7%) -&gt; 2,643 Attended (71.0% show rate)</a:t>
             </a:r>
           </a:p>
           <a:p>
             <a:pPr>
               <a:spcAft>
-                <a:spcPts val="400"/>
+                <a:spcPts val="300"/>
               </a:spcAft>
             </a:pPr>
             <a:r>
-              <a:rPr b="1" i="0" sz="950">
+              <a:rPr b="1" i="0" sz="900">
                 <a:solidFill>
                   <a:srgbClr val="1E1B4B"/>
                 </a:solidFill>
               </a:rPr>
-              <a:t>Demos Scheduled: </a:t>
-            </a:r>
-            <a:r>
-              <a:rPr b="0" i="0" sz="950">
+              <a:t>Cost Per Attended Demo: </a:t>
+            </a:r>
+            <a:r>
+              <a:rPr b="0" i="0" sz="900">
                 <a:solidFill>
                   <a:srgbClr val="0F172A"/>
                 </a:solidFill>
               </a:rPr>
-              <a:t>3,723 Demos (67.7% booking rate via dynamic intake)</a:t>
+              <a:t>$62.12 USD (North-Star KPI connecting media to attendance quality)</a:t>
             </a:r>
           </a:p>
           <a:p>
             <a:pPr>
               <a:spcAft>
-                <a:spcPts val="400"/>
+                <a:spcPts val="300"/>
               </a:spcAft>
             </a:pPr>
             <a:r>
-              <a:rPr b="1" i="0" sz="950">
+              <a:rPr b="1" i="0" sz="900">
                 <a:solidFill>
                   <a:srgbClr val="1E1B4B"/>
                 </a:solidFill>
               </a:rPr>
-              <a:t>Demos Attended: </a:t>
-            </a:r>
-            <a:r>
-              <a:rPr b="0" i="0" sz="950">
+              <a:t>Paid Enrolled Students: </a:t>
+            </a:r>
+            <a:r>
+              <a:rPr b="0" i="0" sz="900">
                 <a:solidFill>
                   <a:srgbClr val="0F172A"/>
                 </a:solidFill>
               </a:rPr>
-              <a:t>2,643 Demos (71.0% show rate via instant calendar lock)</a:t>
+              <a:t>473 Students (17.9% demo close rate | 8.60% full-funnel lead-to-paid)</a:t>
             </a:r>
           </a:p>
           <a:p>
             <a:pPr>
               <a:spcAft>
-                <a:spcPts val="400"/>
+                <a:spcPts val="300"/>
               </a:spcAft>
             </a:pPr>
             <a:r>
-              <a:rPr b="1" i="0" sz="950">
+              <a:rPr b="1" i="0" sz="900">
                 <a:solidFill>
                   <a:srgbClr val="1E1B4B"/>
                 </a:solidFill>
               </a:rPr>
-              <a:t>Paid Students: </a:t>
-            </a:r>
-            <a:r>
-              <a:rPr b="0" i="0" sz="950">
+              <a:t>Round 1 US Calibration: </a:t>
+            </a:r>
+            <a:r>
+              <a:rPr b="0" i="0" sz="900">
                 <a:solidFill>
                   <a:srgbClr val="0F172A"/>
                 </a:solidFill>
               </a:rPr>
-              <a:t>473 Students (17.9% demo close | 8.60% full funnel)</a:t>
+              <a:t>Base 8.60% is modeled ~10% below Round 1 US actual (9.5%)</a:t>
             </a:r>
           </a:p>
           <a:p>
             <a:pPr>
               <a:spcAft>
-                <a:spcPts val="400"/>
+                <a:spcPts val="300"/>
               </a:spcAft>
             </a:pPr>
             <a:r>
-              <a:rPr b="1" i="0" sz="950">
+              <a:rPr b="1" i="0" sz="900">
                 <a:solidFill>
                   <a:srgbClr val="1E1B4B"/>
                 </a:solidFill>
@@ -4472,45 +4472,45 @@
               <a:t>Net Booked Revenue: </a:t>
             </a:r>
             <a:r>
-              <a:rPr b="0" i="0" sz="950">
+              <a:rPr b="0" i="0" sz="900">
                 <a:solidFill>
                   <a:srgbClr val="0F172A"/>
                 </a:solidFill>
               </a:rPr>
-              <a:t>$367,550.00 USD (Exact sum of 3 tiers)</a:t>
+              <a:t>$367,550.00 USD (Net blended ARPU: $777.06 after promo dilution)</a:t>
             </a:r>
           </a:p>
           <a:p>
             <a:pPr>
               <a:spcAft>
-                <a:spcPts val="400"/>
+                <a:spcPts val="300"/>
               </a:spcAft>
             </a:pPr>
             <a:r>
-              <a:rPr b="1" i="0" sz="950">
+              <a:rPr b="1" i="0" sz="900">
                 <a:solidFill>
                   <a:srgbClr val="1E1B4B"/>
                 </a:solidFill>
               </a:rPr>
-              <a:t>Revenue Less Spend: </a:t>
-            </a:r>
-            <a:r>
-              <a:rPr b="0" i="0" sz="950">
+              <a:t>Revenue Less Media Spend: </a:t>
+            </a:r>
+            <a:r>
+              <a:rPr b="0" i="0" sz="900">
                 <a:solidFill>
                   <a:srgbClr val="0F172A"/>
                 </a:solidFill>
               </a:rPr>
-              <a:t>$203,375.00 USD (Net margin after digital media)</a:t>
+              <a:t>$203,375.00 USD (Direct gross margin after advertising)</a:t>
             </a:r>
           </a:p>
           <a:p>
             <a:pPr>
               <a:spcAft>
-                <a:spcPts val="400"/>
+                <a:spcPts val="300"/>
               </a:spcAft>
             </a:pPr>
             <a:r>
-              <a:rPr b="1" i="0" sz="950">
+              <a:rPr b="1" i="0" sz="900">
                 <a:solidFill>
                   <a:srgbClr val="1E1B4B"/>
                 </a:solidFill>
@@ -4518,22 +4518,22 @@
               <a:t>Assumed Gross Margin: </a:t>
             </a:r>
             <a:r>
-              <a:rPr b="0" i="0" sz="950">
+              <a:rPr b="0" i="0" sz="900">
                 <a:solidFill>
                   <a:srgbClr val="0F172A"/>
                 </a:solidFill>
               </a:rPr>
-              <a:t>55.0% (Assumed: 40% mentor payout + 5% platform infra)</a:t>
+              <a:t>55.0% (Assumed: 40% mentor payout + 5% platform COGS)</a:t>
             </a:r>
           </a:p>
           <a:p>
             <a:pPr>
               <a:spcAft>
-                <a:spcPts val="400"/>
+                <a:spcPts val="300"/>
               </a:spcAft>
             </a:pPr>
             <a:r>
-              <a:rPr b="1" i="0" sz="950">
+              <a:rPr b="1" i="0" sz="900">
                 <a:solidFill>
                   <a:srgbClr val="1E1B4B"/>
                 </a:solidFill>
@@ -4541,30 +4541,30 @@
               <a:t>Contribution Margin: </a:t>
             </a:r>
             <a:r>
-              <a:rPr b="0" i="0" sz="950">
+              <a:rPr b="0" i="0" sz="900">
                 <a:solidFill>
                   <a:srgbClr val="0F172A"/>
                 </a:solidFill>
               </a:rPr>
-              <a:t>$37,977.50 USD (Profit after media &amp; instructional delivery)</a:t>
+              <a:t>$37,977.50 USD (10.3% margin before closers, payment fees, refunds, creative)</a:t>
             </a:r>
           </a:p>
           <a:p>
             <a:pPr>
               <a:spcAft>
-                <a:spcPts val="400"/>
+                <a:spcPts val="300"/>
               </a:spcAft>
             </a:pPr>
             <a:r>
-              <a:rPr b="1" i="0" sz="950">
+              <a:rPr b="1" i="0" sz="900">
                 <a:solidFill>
                   <a:srgbClr val="1E1B4B"/>
                 </a:solidFill>
               </a:rPr>
-              <a:t>First-Order ROAS: </a:t>
-            </a:r>
-            <a:r>
-              <a:rPr b="0" i="0" sz="950">
+              <a:t>First-Order Media ROAS: </a:t>
+            </a:r>
+            <a:r>
+              <a:rPr b="0" i="0" sz="900">
                 <a:solidFill>
                   <a:srgbClr val="0F172A"/>
                 </a:solidFill>
@@ -4575,24 +4575,24 @@
           <a:p>
             <a:pPr>
               <a:spcAft>
-                <a:spcPts val="400"/>
+                <a:spcPts val="300"/>
               </a:spcAft>
             </a:pPr>
             <a:r>
-              <a:rPr b="1" i="0" sz="950">
+              <a:rPr b="1" i="0" sz="900">
                 <a:solidFill>
                   <a:srgbClr val="1E1B4B"/>
                 </a:solidFill>
               </a:rPr>
-              <a:t>Blended CAC: </a:t>
-            </a:r>
-            <a:r>
-              <a:rPr b="0" i="0" sz="950">
+              <a:t>First-Order GM LTV/CAC: </a:t>
+            </a:r>
+            <a:r>
+              <a:rPr b="0" i="0" sz="900">
                 <a:solidFill>
                   <a:srgbClr val="0F172A"/>
                 </a:solidFill>
               </a:rPr>
-              <a:t>$347.09 USD per enrolled student</a:t>
+              <a:t>1.23x ($777.06 x 55% GM / $347.09 CAC; excludes renewals)</a:t>
             </a:r>
           </a:p>
         </p:txBody>
@@ -4606,7 +4606,7 @@
         <p:spPr>
           <a:xfrm>
             <a:off x="8046720" y="1371600"/>
-            <a:ext cx="3383280" cy="2286000"/>
+            <a:ext cx="3383280" cy="2377440"/>
           </a:xfrm>
           <a:prstGeom prst="roundRect">
             <a:avLst/>
@@ -4651,7 +4651,7 @@
         <p:spPr>
           <a:xfrm>
             <a:off x="8183879" y="1508760"/>
-            <a:ext cx="3108960" cy="2011680"/>
+            <a:ext cx="3108960" cy="2103120"/>
           </a:xfrm>
           <a:prstGeom prst="rect">
             <a:avLst/>
@@ -4690,7 +4690,7 @@
                   <a:srgbClr val="1E1B4B"/>
                 </a:solidFill>
               </a:rPr>
-              <a:t>1. Q4 Ad Auction Inflation: </a:t>
+              <a:t>1. Q4 Ad Auction CPM Spikes: </a:t>
             </a:r>
             <a:r>
               <a:rPr b="0" i="0" sz="850">
@@ -4698,7 +4698,7 @@
                   <a:srgbClr val="0F172A"/>
                 </a:solidFill>
               </a:rPr>
-              <a:t>Retail CPMs surge 25%+ during BFCM. Mitigate via front-loaded Nov 1-18 pacing, strict $42 bid caps, and gift positioning.</a:t>
+              <a:t>CPMs surge 40-60% during BFCM. Mitigate via front-loaded Nov 1-18 pacing, 50% Thanksgiving pause &amp; $42 bid caps.</a:t>
             </a:r>
           </a:p>
           <a:p>
@@ -4708,7 +4708,7 @@
                   <a:srgbClr val="1E1B4B"/>
                 </a:solidFill>
               </a:rPr>
-              <a:t>2. Demo Timezone Bottlenecks: </a:t>
+              <a:t>2. Weekend Peak Demo Demand: </a:t>
             </a:r>
             <a:r>
               <a:rPr b="0" i="0" sz="850">
@@ -4716,7 +4716,7 @@
                   <a:srgbClr val="0F172A"/>
                 </a:solidFill>
               </a:rPr>
-              <a:t>62 demos/day clustered in 4:30-8:30 PM local slots. Mitigate with dedicated 16-mentor US pod across EST/CST/PST.</a:t>
+              <a:t>1.6x weekend surge pushes demand to 74.4 hrs (&gt;100% capacity). Mitigate via weekend daytime blocks (10 AM-3 PM) &amp; 6 flex mentors.</a:t>
             </a:r>
           </a:p>
         </p:txBody>
@@ -4729,8 +4729,8 @@
         </p:nvSpPr>
         <p:spPr>
           <a:xfrm>
-            <a:off x="8046720" y="3840480"/>
-            <a:ext cx="3383280" cy="2468880"/>
+            <a:off x="8046720" y="3931920"/>
+            <a:ext cx="3383280" cy="2377440"/>
           </a:xfrm>
           <a:prstGeom prst="roundRect">
             <a:avLst/>
@@ -4774,8 +4774,8 @@
         </p:nvSpPr>
         <p:spPr>
           <a:xfrm>
-            <a:off x="8183879" y="3977639"/>
-            <a:ext cx="3108960" cy="2194560"/>
+            <a:off x="8183879" y="4069080"/>
+            <a:ext cx="3108960" cy="2103120"/>
           </a:xfrm>
           <a:prstGeom prst="rect">
             <a:avLst/>
@@ -4814,7 +4814,7 @@
                   <a:srgbClr val="1E1B4B"/>
                 </a:solidFill>
               </a:rPr>
-              <a:t>1. Budget Approval: Authorize $164,175 media pacing ($74.6k Nov / $89.5k Dec).</a:t>
+              <a:t>1. Budget Approval: Authorize $164,175 media plan ($77k Nov / $87.2k Dec).</a:t>
             </a:r>
           </a:p>
           <a:p>
@@ -4829,7 +4829,7 @@
                   <a:srgbClr val="1E1B4B"/>
                 </a:solidFill>
               </a:rPr>
-              <a:t>2. Counselor Pod: Roster 16 dedicated US-shift mentors for peak 4:30-8:30 PM slots.</a:t>
+              <a:t>2. Counselor Capacity: Confirm 16 dedicated US-shift mentors + 6 flex pool.</a:t>
             </a:r>
           </a:p>
           <a:p>
@@ -4844,7 +4844,7 @@
                   <a:srgbClr val="1E1B4B"/>
                 </a:solidFill>
               </a:rPr>
-              <a:t>3. Holiday Voucher: Authorize $150 Black Friday/Holiday scholarship grant.</a:t>
+              <a:t>3. Holiday Voucher A/B Test: Authorize $150 voucher test vs premium control.</a:t>
             </a:r>
           </a:p>
         </p:txBody>
@@ -5042,12 +5042,12 @@
               </a:defRPr>
             </a:pPr>
             <a:r>
-              <a:t>Meta lead forms optimized on volume attract low-intent clickers, grandparents with wrong numbers, or kids without laptops.</a:t>
+              <a:t>Meta lead forms optimized on volume attract low-intent clickers, grandparents entering wrong numbers, or kids without laptop access.</a:t>
             </a:r>
             <a:br/>
             <a:br/>
             <a:r>
-              <a:t>Result: Demo show rate collapses to &lt;30%, burning sales counselor payroll and producing zero enrolled revenue.</a:t>
+              <a:t>Result: Demo show rate collapses to &lt;30%, burning counselor payroll on empty Zoom rooms.</a:t>
             </a:r>
           </a:p>
         </p:txBody>
@@ -5162,7 +5162,7 @@
             <a:br/>
             <a:br/>
             <a:r>
-              <a:t>Result: High trial conversion (25%+), but volume caps at &lt;800 leads and blows past the $30 CPL mandate ceiling.</a:t>
+              <a:t>Result: High trial conversion (25%+), but volume caps at &lt;800 leads and blows far past the $30 CPL mandate ceiling.</a:t>
             </a:r>
           </a:p>
         </p:txBody>
@@ -5280,7 +5280,7 @@
             </a:r>
             <a:br/>
             <a:r>
-              <a:t>• Server-Side Meta CAPI with monotonic expected values + instant calendar booking (&lt;=48h lag).</a:t>
+              <a:t>• Server-Side Meta CAPI v21.0 optimized on Schedule + dynamic intake with OTP and instant calendar lock (&lt;=48h).</a:t>
             </a:r>
           </a:p>
         </p:txBody>
@@ -5368,7 +5368,7 @@
               </a:defRPr>
             </a:pPr>
             <a:r>
-              <a:t>2. Pillar 1: Compliant Meta Targeting &amp; Mutually Exclusive Geos</a:t>
+              <a:t>2. Pillar 1: Compliant Diaspora Wedge &amp; Advantage+ Control Arm</a:t>
             </a:r>
           </a:p>
         </p:txBody>
@@ -5382,7 +5382,7 @@
         <p:spPr>
           <a:xfrm>
             <a:off x="731520" y="1371600"/>
-            <a:ext cx="5120640" cy="4937760"/>
+            <a:ext cx="5303520" cy="4937760"/>
           </a:xfrm>
           <a:prstGeom prst="roundRect">
             <a:avLst/>
@@ -5427,7 +5427,7 @@
         <p:spPr>
           <a:xfrm>
             <a:off x="914400" y="1508760"/>
-            <a:ext cx="4754880" cy="4663440"/>
+            <a:ext cx="4937760" cy="4663440"/>
           </a:xfrm>
           <a:prstGeom prst="rect">
             <a:avLst/>
@@ -5442,7 +5442,7 @@
           <a:p>
             <a:pPr>
               <a:spcAft>
-                <a:spcPts val="800"/>
+                <a:spcPts val="600"/>
               </a:spcAft>
               <a:defRPr sz="1050" b="1">
                 <a:solidFill>
@@ -5451,22 +5451,7 @@
               </a:defRPr>
             </a:pPr>
             <a:r>
-              <a:t>HOW DIASPORA &amp; STEM TARGETING IS ACHIEVED ON META</a:t>
-            </a:r>
-          </a:p>
-          <a:p>
-            <a:pPr>
-              <a:spcAft>
-                <a:spcPts val="1000"/>
-              </a:spcAft>
-              <a:defRPr sz="900" i="1">
-                <a:solidFill>
-                  <a:srgbClr val="64748B"/>
-                </a:solidFill>
-              </a:defRPr>
-            </a:pPr>
-            <a:r>
-              <a:t>Important: Ethnic affinity targeting is prohibited and unavailable on Meta. We achieve precision targeting via 3 compliant operational proxies:</a:t>
+              <a:t>HOW DIASPORA &amp; STEM AUDIENCES ARE REACHED COMPLIANTLY</a:t>
             </a:r>
           </a:p>
           <a:p>
@@ -5474,68 +5459,129 @@
               <a:spcAft>
                 <a:spcPts val="800"/>
               </a:spcAft>
-            </a:pPr>
-            <a:r>
-              <a:rPr b="1" i="0" sz="950">
+              <a:defRPr sz="850" i="1">
+                <a:solidFill>
+                  <a:srgbClr val="64748B"/>
+                </a:solidFill>
+              </a:defRPr>
+            </a:pPr>
+            <a:r>
+              <a:t>Policy Context: Meta removed ethnicity and race detailed targeting options, and delivery is increasingly algorithmic. Direct ethnic targeting is prohibited. We reach high-propensity families through 6 operational proxies:</a:t>
+            </a:r>
+          </a:p>
+          <a:p>
+            <a:pPr>
+              <a:spcAft>
+                <a:spcPts val="400"/>
+              </a:spcAft>
+            </a:pPr>
+            <a:r>
+              <a:rPr b="1" i="0" sz="850">
                 <a:solidFill>
                   <a:srgbClr val="1E1B4B"/>
                 </a:solidFill>
               </a:rPr>
-              <a:t>1. High-Density Zip-Code Geo Clusters: </a:t>
-            </a:r>
-            <a:r>
-              <a:rPr b="0" i="0" sz="950">
+              <a:t>1. Value-Based Lookalikes from Paid US Customers: </a:t>
+            </a:r>
+            <a:r>
+              <a:rPr b="0" i="0" sz="850">
                 <a:solidFill>
                   <a:srgbClr val="0F172A"/>
                 </a:solidFill>
               </a:rPr>
-              <a:t>Targeting premier STEM school districts with high concentrations of engineering families (Fremont 94539, Sunnyvale 94087, Frisco 75034, Edison 08820, Bellevue 98052).</a:t>
+              <a:t>Seeded from paying customer lists; Meta ML organically skews to diaspora families based on behavioral and cultural signals.</a:t>
             </a:r>
           </a:p>
           <a:p>
             <a:pPr>
               <a:spcAft>
-                <a:spcPts val="800"/>
+                <a:spcPts val="400"/>
               </a:spcAft>
             </a:pPr>
             <a:r>
-              <a:rPr b="1" i="0" sz="950">
+              <a:rPr b="1" i="0" sz="850">
                 <a:solidFill>
                   <a:srgbClr val="1E1B4B"/>
                 </a:solidFill>
               </a:rPr>
-              <a:t>2. Academic &amp; Cultural Interest Proxies: </a:t>
-            </a:r>
-            <a:r>
-              <a:rPr b="0" i="0" sz="950">
+              <a:t>2. Zip-Code Clustering in Premier School Districts: </a:t>
+            </a:r>
+            <a:r>
+              <a:rPr b="0" i="0" sz="850">
                 <a:solidFill>
                   <a:srgbClr val="0F172A"/>
                 </a:solidFill>
               </a:rPr>
-              <a:t>Parents (30-55) indexing heavily on Kumon, Russian School of Math (RSM), Mathnasium, Singapore Math, USACO, First Robotics, and Chess.com.</a:t>
+              <a:t>Top STEM school districts (Fremont 94539, Sunnyvale 94087, Frisco 75034, Edison 08820, Bellevue 98052, Alpharetta 30005, Cary 27519).</a:t>
             </a:r>
           </a:p>
           <a:p>
             <a:pPr>
               <a:spcAft>
-                <a:spcPts val="800"/>
+                <a:spcPts val="400"/>
               </a:spcAft>
             </a:pPr>
             <a:r>
-              <a:rPr b="1" i="0" sz="950">
+              <a:rPr b="1" i="0" sz="850">
                 <a:solidFill>
                   <a:srgbClr val="1E1B4B"/>
                 </a:solidFill>
               </a:rPr>
-              <a:t>3. 1% Lookalikes from US Customer Lists: </a:t>
-            </a:r>
-            <a:r>
-              <a:rPr b="0" i="0" sz="950">
+              <a:t>3. Academic Program Proxies: </a:t>
+            </a:r>
+            <a:r>
+              <a:rPr b="0" i="0" sz="850">
                 <a:solidFill>
                   <a:srgbClr val="0F172A"/>
                 </a:solidFill>
               </a:rPr>
-              <a:t>Ingesting historical US paid customer seed lists (SHA-256 hashed parent emails/phones) to train Meta lookalikes.</a:t>
+              <a:t>Parents (30-55) engaging with Kumon, Russian School of Math (RSM), Mathnasium, Singapore Math, USACO, and FIRST Robotics.</a:t>
+            </a:r>
+          </a:p>
+          <a:p>
+            <a:pPr>
+              <a:spcAft>
+                <a:spcPts val="400"/>
+              </a:spcAft>
+            </a:pPr>
+            <a:r>
+              <a:rPr b="1" i="0" sz="850">
+                <a:solidFill>
+                  <a:srgbClr val="1E1B4B"/>
+                </a:solidFill>
+              </a:rPr>
+              <a:t>4. Community &amp; Referral Channels: </a:t>
+            </a:r>
+            <a:r>
+              <a:rPr b="0" i="0" sz="850">
+                <a:solidFill>
+                  <a:srgbClr val="0F172A"/>
+                </a:solidFill>
+              </a:rPr>
+              <a:t>In Round 1, US referral leads converted at 11.9% lead-to-paid vs 9.7% for Meta. Amplified via dedicated parent referral loops.</a:t>
+            </a:r>
+          </a:p>
+          <a:p>
+            <a:pPr>
+              <a:spcAft>
+                <a:spcPts val="400"/>
+              </a:spcAft>
+            </a:pPr>
+            <a:r>
+              <a:rPr b="1" i="0" sz="850">
+                <a:solidFill>
+                  <a:srgbClr val="1E1B4B"/>
+                </a:solidFill>
+              </a:rPr>
+              <a:t>5. Broad / Advantage+ Control Arm (10-15% Budget): </a:t>
+            </a:r>
+            <a:r>
+              <a:rPr b="0" i="0" sz="850">
+                <a:solidFill>
+                  <a:srgbClr val="0F172A"/>
+                </a:solidFill>
+              </a:rPr>
+              <a:t>Unconstrained algorithmic delivery to empirically test if geo tiers beat Meta's algorithm on Cost Per Attended Demo ($62.12 baseline).</a:t>
             </a:r>
           </a:p>
         </p:txBody>
@@ -5648,11 +5694,10 @@
                   <a:srgbClr val="0F172A"/>
                 </a:solidFill>
               </a:rPr>
-              <a:t>• SF Bay Area: Fremont, Sunnyvale, Cupertino, Dublin, San Jose
+              <a:t>• SF Bay Area: Fremont, Sunnyvale, Cupertino, San Jose
 • Seattle Belt: Bellevue, Redmond, Kirkland
-• DFW Tech Wedge: Frisco, Plano, Irving/Coppell
-• NJ/NYC Metro: Edison, Iselin, Jersey City
-• Austin Hub: Austin, Round Rock</a:t>
+• DFW Tech Wedge: Frisco, Plano, Irving
+• NJ/NYC Metro: Edison, Iselin, Jersey City | Austin Hub: Austin, Round Rock</a:t>
             </a:r>
           </a:p>
           <a:p>
@@ -5683,10 +5728,8 @@
                 </a:solidFill>
               </a:rPr>
               <a:t>• North Atlanta: Alpharetta, Johns Creek, Milton
-• RTP NC: Cary, Morrisville, Apex
-• Chicago Suburbs: Naperville, Aurora, Schaumburg
-• Northern VA: Fairfax, Ashburn, McLean
-• Orange County CA: Irvine, San Diego North
+• RTP NC: Cary, Morrisville, Apex | Chicago Suburbs: Naperville
+• Northern VA: Fairfax, Ashburn | Orange County CA: Irvine
 • Houston Suburbs: Sugar Land, Katy | Boston: Lexington, Newton</a:t>
             </a:r>
           </a:p>
@@ -5717,7 +5760,7 @@
                   <a:srgbClr val="0F172A"/>
                 </a:solidFill>
               </a:rPr>
-              <a:t>• Non-metro Sunbelt, Ohio, Indiana, Michigan, Missouri, Kansas, Iowa, Wisconsin, Inland Pennsylvania.</a:t>
+              <a:t>• Non-metro Sunbelt, Midwest, Ohio, Indiana, Michigan, Missouri, Kansas, Iowa, Wisconsin, Inland Pennsylvania.</a:t>
             </a:r>
           </a:p>
         </p:txBody>
@@ -5805,7 +5848,7 @@
               </a:defRPr>
             </a:pPr>
             <a:r>
-              <a:t>3. Funnel Hypotheses to Validate: Operational Tier Economics</a:t>
+              <a:t>3. Funnel Hypotheses &amp; Single-Source-of-Truth Tier Economics</a:t>
             </a:r>
           </a:p>
         </p:txBody>
@@ -5878,14 +5921,14 @@
           <a:lstStyle/>
           <a:p>
             <a:pPr>
-              <a:defRPr sz="900" b="1">
+              <a:defRPr sz="850" b="1">
                 <a:solidFill>
                   <a:srgbClr val="1E1B4B"/>
                 </a:solidFill>
               </a:defRPr>
             </a:pPr>
             <a:r>
-              <a:t>EMPIRICAL HYPOTHESES TO VALIDATE: All tier CPLs and conversion rates represent testable operational hypotheses monitored during Days 1-10.</a:t>
+              <a:t>EMPIRICAL HYPOTHESES TO VALIDATE: Round 1 has no zip/income fields. Tier close rates (22/17/13%) and ARPUs ($850/$750/$650) are testable hypotheses to validate in Days 1-10.</a:t>
             </a:r>
           </a:p>
         </p:txBody>
@@ -5900,7 +5943,7 @@
         </p:nvGraphicFramePr>
         <p:xfrm>
           <a:off x="731520" y="2011680"/>
-          <a:ext cx="10643616" cy="2926080"/>
+          <a:ext cx="10698480" cy="2926080"/>
         </p:xfrm>
         <a:graphic>
           <a:graphicData uri="http://schemas.openxmlformats.org/drawingml/2006/table">
@@ -5909,14 +5952,14 @@
                 <a:tableStyleId>{5C22544A-7EE6-4342-B048-85BDC9FD1C3A}</a:tableStyleId>
               </a:tblPr>
               <a:tblGrid>
-                <a:gridCol w="2194560"/>
-                <a:gridCol w="1207008"/>
-                <a:gridCol w="1207008"/>
-                <a:gridCol w="1207008"/>
-                <a:gridCol w="1207008"/>
-                <a:gridCol w="1207008"/>
-                <a:gridCol w="1207008"/>
-                <a:gridCol w="1207008"/>
+                <a:gridCol w="2103120"/>
+                <a:gridCol w="1005840"/>
+                <a:gridCol w="1005840"/>
+                <a:gridCol w="1188720"/>
+                <a:gridCol w="1280160"/>
+                <a:gridCol w="1280160"/>
+                <a:gridCol w="1280160"/>
+                <a:gridCol w="1554480"/>
               </a:tblGrid>
               <a:tr h="585216">
                 <a:tc>
@@ -5925,7 +5968,7 @@
                     <a:lstStyle/>
                     <a:p>
                       <a:pPr>
-                        <a:defRPr sz="850" b="1">
+                        <a:defRPr sz="800" b="1">
                           <a:solidFill>
                             <a:srgbClr val="FFFFFF"/>
                           </a:solidFill>
@@ -5948,7 +5991,7 @@
                     <a:lstStyle/>
                     <a:p>
                       <a:pPr>
-                        <a:defRPr sz="850" b="1">
+                        <a:defRPr sz="800" b="1">
                           <a:solidFill>
                             <a:srgbClr val="FFFFFF"/>
                           </a:solidFill>
@@ -5971,7 +6014,7 @@
                     <a:lstStyle/>
                     <a:p>
                       <a:pPr>
-                        <a:defRPr sz="850" b="1">
+                        <a:defRPr sz="800" b="1">
                           <a:solidFill>
                             <a:srgbClr val="FFFFFF"/>
                           </a:solidFill>
@@ -5994,7 +6037,7 @@
                     <a:lstStyle/>
                     <a:p>
                       <a:pPr>
-                        <a:defRPr sz="850" b="1">
+                        <a:defRPr sz="800" b="1">
                           <a:solidFill>
                             <a:srgbClr val="FFFFFF"/>
                           </a:solidFill>
@@ -6017,14 +6060,14 @@
                     <a:lstStyle/>
                     <a:p>
                       <a:pPr>
-                        <a:defRPr sz="850" b="1">
+                        <a:defRPr sz="800" b="1">
                           <a:solidFill>
                             <a:srgbClr val="FFFFFF"/>
                           </a:solidFill>
                         </a:defRPr>
                       </a:pPr>
                       <a:r>
-                        <a:t>Sched Rate</a:t>
+                        <a:t>Cost/Attended</a:t>
                       </a:r>
                     </a:p>
                   </a:txBody>
@@ -6040,7 +6083,7 @@
                     <a:lstStyle/>
                     <a:p>
                       <a:pPr>
-                        <a:defRPr sz="850" b="1">
+                        <a:defRPr sz="800" b="1">
                           <a:solidFill>
                             <a:srgbClr val="FFFFFF"/>
                           </a:solidFill>
@@ -6063,7 +6106,7 @@
                     <a:lstStyle/>
                     <a:p>
                       <a:pPr>
-                        <a:defRPr sz="850" b="1">
+                        <a:defRPr sz="800" b="1">
                           <a:solidFill>
                             <a:srgbClr val="FFFFFF"/>
                           </a:solidFill>
@@ -6086,7 +6129,7 @@
                     <a:lstStyle/>
                     <a:p>
                       <a:pPr>
-                        <a:defRPr sz="850" b="1">
+                        <a:defRPr sz="800" b="1">
                           <a:solidFill>
                             <a:srgbClr val="FFFFFF"/>
                           </a:solidFill>
@@ -6210,7 +6253,7 @@
                         </a:defRPr>
                       </a:pPr>
                       <a:r>
-                        <a:t>72.0% (1,188)</a:t>
+                        <a:t>$65.78</a:t>
                       </a:r>
                     </a:p>
                   </a:txBody>
@@ -6396,7 +6439,7 @@
                         </a:defRPr>
                       </a:pPr>
                       <a:r>
-                        <a:t>68.0% (1,683)</a:t>
+                        <a:t>$60.06</a:t>
                       </a:r>
                     </a:p>
                   </a:txBody>
@@ -6582,7 +6625,7 @@
                         </a:defRPr>
                       </a:pPr>
                       <a:r>
-                        <a:t>62.0% (852)</a:t>
+                        <a:t>$60.55</a:t>
                       </a:r>
                     </a:p>
                   </a:txBody>
@@ -6768,7 +6811,7 @@
                         </a:defRPr>
                       </a:pPr>
                       <a:r>
-                        <a:t>67.7% (3,723)</a:t>
+                        <a:t>$62.12</a:t>
                       </a:r>
                     </a:p>
                   </a:txBody>
@@ -6927,27 +6970,27 @@
               </a:defRPr>
             </a:pPr>
             <a:r>
-              <a:t>MATHEMATICAL PROOF OF MANDATE RECONCILIATION:</a:t>
-            </a:r>
-          </a:p>
-          <a:p>
-            <a:pPr>
-              <a:defRPr sz="900">
+              <a:t>MATHEMATICAL PROOF &amp; MONTHLY PACING:</a:t>
+            </a:r>
+          </a:p>
+          <a:p>
+            <a:pPr>
+              <a:defRPr sz="850">
                 <a:solidFill>
                   <a:srgbClr val="0F172A"/>
                 </a:solidFill>
               </a:defRPr>
             </a:pPr>
             <a:r>
-              <a:t>• Blended CPL = (0.30 x $36.00) + (0.45 x $29.00) + (0.25 x $24.00) = $10.80 + $13.05 + $6.00 = $29.85 USD (Under $30.00 mandate).</a:t>
+              <a:t>• Blended CPL = (0.30 x $36) + (0.45 x $29) + (0.25 x $24) = $29.85 USD | Cost Per Attended Demo = $62.12 USD.</a:t>
             </a:r>
             <a:br/>
             <a:r>
-              <a:t>• Exact Net Revenue Sum = $169,150 + $152,250 + $46,150 = $367,550.00 USD (Gross list $414,850 - $47,300 promo voucher dilution).</a:t>
+              <a:t>• Monthly Pacing: November (2,500 leads @ $30.80 CPL = $77k; 50% Thanksgiving pause) | December (3,000 leads @ $29.06 CPL = $87,175).</a:t>
             </a:r>
             <a:br/>
             <a:r>
-              <a:t>• Revenue Less Media Spend = $367,550 - $164,175 = $203,375.00 USD | Blended CAC = $347.09 per paid student.</a:t>
+              <a:t>• Contingency Rule: If weekly blended CPL &gt; $33, shift budget to Tier 2/3 suburban zips and referral channels before cutting volume.</a:t>
             </a:r>
           </a:p>
         </p:txBody>
@@ -7035,7 +7078,7 @@
               </a:defRPr>
             </a:pPr>
             <a:r>
-              <a:t>4. Scenario Planning, Sensitivity &amp; Break-Even ROAS Proof</a:t>
+              <a:t>4. Scenario Planning, Sensitivity &amp; Break-Even Thresholds</a:t>
             </a:r>
           </a:p>
         </p:txBody>
@@ -7360,7 +7403,7 @@
                         </a:defRPr>
                       </a:pPr>
                       <a:r>
-                        <a:t>Show Rate (%)</a:t>
+                        <a:t>Cost / Attended Demo ($)</a:t>
                       </a:r>
                     </a:p>
                   </a:txBody>
@@ -7383,7 +7426,7 @@
                         </a:defRPr>
                       </a:pPr>
                       <a:r>
-                        <a:t>55.0% (Ghosting)</a:t>
+                        <a:t>$100.69</a:t>
                       </a:r>
                     </a:p>
                   </a:txBody>
@@ -7406,7 +7449,7 @@
                         </a:defRPr>
                       </a:pPr>
                       <a:r>
-                        <a:t>71.0%</a:t>
+                        <a:t>$62.12</a:t>
                       </a:r>
                     </a:p>
                   </a:txBody>
@@ -7429,7 +7472,7 @@
                         </a:defRPr>
                       </a:pPr>
                       <a:r>
-                        <a:t>76.0%</a:t>
+                        <a:t>$50.52</a:t>
                       </a:r>
                     </a:p>
                   </a:txBody>
@@ -7454,7 +7497,7 @@
                         </a:defRPr>
                       </a:pPr>
                       <a:r>
-                        <a:t>Enrolled Students</a:t>
+                        <a:t>Show Rate (%)</a:t>
                       </a:r>
                     </a:p>
                   </a:txBody>
@@ -7477,7 +7520,7 @@
                         </a:defRPr>
                       </a:pPr>
                       <a:r>
-                        <a:t>262</a:t>
+                        <a:t>55.0% (Ghosting)</a:t>
                       </a:r>
                     </a:p>
                   </a:txBody>
@@ -7500,7 +7543,7 @@
                         </a:defRPr>
                       </a:pPr>
                       <a:r>
-                        <a:t>473</a:t>
+                        <a:t>71.0%</a:t>
                       </a:r>
                     </a:p>
                   </a:txBody>
@@ -7523,7 +7566,7 @@
                         </a:defRPr>
                       </a:pPr>
                       <a:r>
-                        <a:t>585</a:t>
+                        <a:t>76.0%</a:t>
                       </a:r>
                     </a:p>
                   </a:txBody>
@@ -7548,7 +7591,7 @@
                         </a:defRPr>
                       </a:pPr>
                       <a:r>
-                        <a:t>Blended CAC ($)</a:t>
+                        <a:t>Enrolled Students</a:t>
                       </a:r>
                     </a:p>
                   </a:txBody>
@@ -7571,7 +7614,7 @@
                         </a:defRPr>
                       </a:pPr>
                       <a:r>
-                        <a:t>$720.62</a:t>
+                        <a:t>262</a:t>
                       </a:r>
                     </a:p>
                   </a:txBody>
@@ -7594,7 +7637,7 @@
                         </a:defRPr>
                       </a:pPr>
                       <a:r>
-                        <a:t>$347.09</a:t>
+                        <a:t>473</a:t>
                       </a:r>
                     </a:p>
                   </a:txBody>
@@ -7617,7 +7660,7 @@
                         </a:defRPr>
                       </a:pPr>
                       <a:r>
-                        <a:t>$252.58</a:t>
+                        <a:t>585</a:t>
                       </a:r>
                     </a:p>
                   </a:txBody>
@@ -7642,7 +7685,7 @@
                         </a:defRPr>
                       </a:pPr>
                       <a:r>
-                        <a:t>Net Revenue ($)</a:t>
+                        <a:t>Net Booked Revenue ($)</a:t>
                       </a:r>
                     </a:p>
                   </a:txBody>
@@ -7736,7 +7779,7 @@
                         </a:defRPr>
                       </a:pPr>
                       <a:r>
-                        <a:t>First-Order ROAS</a:t>
+                        <a:t>First-Order Media ROAS</a:t>
                       </a:r>
                     </a:p>
                   </a:txBody>
@@ -7830,7 +7873,7 @@
                         </a:defRPr>
                       </a:pPr>
                       <a:r>
-                        <a:t>Contrib Margin ($)</a:t>
+                        <a:t>Contribution Margin ($)</a:t>
                       </a:r>
                     </a:p>
                   </a:txBody>
@@ -7983,49 +8026,108 @@
           <a:p>
             <a:pPr>
               <a:spcAft>
-                <a:spcPts val="600"/>
+                <a:spcPts val="400"/>
               </a:spcAft>
-              <a:defRPr sz="1000" b="1">
+              <a:defRPr sz="950" b="1">
                 <a:solidFill>
                   <a:srgbClr val="4338CA"/>
                 </a:solidFill>
               </a:defRPr>
             </a:pPr>
             <a:r>
-              <a:t>BREAK-EVEN ROAS AT 55% GROSS MARGIN</a:t>
+              <a:t>BREAK-EVEN THRESHOLDS (FINANCIAL GUARDRAILS)</a:t>
             </a:r>
           </a:p>
           <a:p>
             <a:pPr>
               <a:spcAft>
-                <a:spcPts val="1000"/>
+                <a:spcPts val="200"/>
               </a:spcAft>
-              <a:defRPr sz="850">
+            </a:pPr>
+            <a:r>
+              <a:rPr b="1" i="0" sz="800">
+                <a:solidFill>
+                  <a:srgbClr val="1E1B4B"/>
+                </a:solidFill>
+              </a:rPr>
+              <a:t>Break-Even CPL: </a:t>
+            </a:r>
+            <a:r>
+              <a:rPr b="0" i="0" sz="800">
                 <a:solidFill>
                   <a:srgbClr val="0F172A"/>
                 </a:solidFill>
-              </a:defRPr>
-            </a:pPr>
-            <a:r>
-              <a:t>Assumed Gross Margin: 55.0%</a:t>
-            </a:r>
-            <a:br/>
-            <a:r>
-              <a:t>(40% mentor payout + 5% platform SaaS)</a:t>
-            </a:r>
-            <a:br/>
-            <a:br/>
-            <a:r>
-              <a:t>Break-Even Formula:</a:t>
-            </a:r>
-            <a:br/>
-            <a:r>
-              <a:t>ROAS = 1 / Gross Margin = 1 / 0.55 = 1.82x</a:t>
-            </a:r>
-            <a:br/>
-            <a:br/>
-            <a:r>
-              <a:t>Base Case Delivers 2.24x ROAS, securing $37,977.50 in net contribution profit from Day 1.</a:t>
+              </a:rPr>
+              <a:t>$36.76 (Max CPL before contribution turns negative: $367.5k x 0.55 / 5.5k).</a:t>
+            </a:r>
+          </a:p>
+          <a:p>
+            <a:pPr>
+              <a:spcAft>
+                <a:spcPts val="200"/>
+              </a:spcAft>
+            </a:pPr>
+            <a:r>
+              <a:rPr b="1" i="0" sz="800">
+                <a:solidFill>
+                  <a:srgbClr val="1E1B4B"/>
+                </a:solidFill>
+              </a:rPr>
+              <a:t>Break-Even Gross Margin: </a:t>
+            </a:r>
+            <a:r>
+              <a:rPr b="0" i="0" sz="800">
+                <a:solidFill>
+                  <a:srgbClr val="0F172A"/>
+                </a:solidFill>
+              </a:rPr>
+              <a:t>44.7% (Minimum GM to cover $164k spend: $164k / $367.5k).</a:t>
+            </a:r>
+          </a:p>
+          <a:p>
+            <a:pPr>
+              <a:spcAft>
+                <a:spcPts val="200"/>
+              </a:spcAft>
+            </a:pPr>
+            <a:r>
+              <a:rPr b="1" i="0" sz="800">
+                <a:solidFill>
+                  <a:srgbClr val="1E1B4B"/>
+                </a:solidFill>
+              </a:rPr>
+              <a:t>Break-Even Close Rate: </a:t>
+            </a:r>
+            <a:r>
+              <a:rPr b="0" i="0" sz="800">
+                <a:solidFill>
+                  <a:srgbClr val="0F172A"/>
+                </a:solidFill>
+              </a:rPr>
+              <a:t>14.5% (Minimum close rate required at 2,643 attended demos).</a:t>
+            </a:r>
+          </a:p>
+          <a:p>
+            <a:pPr>
+              <a:spcAft>
+                <a:spcPts val="200"/>
+              </a:spcAft>
+            </a:pPr>
+            <a:r>
+              <a:rPr b="1" i="0" sz="800">
+                <a:solidFill>
+                  <a:srgbClr val="1E1B4B"/>
+                </a:solidFill>
+              </a:rPr>
+              <a:t>Break-Even Media ROAS: </a:t>
+            </a:r>
+            <a:r>
+              <a:rPr b="0" i="0" sz="800">
+                <a:solidFill>
+                  <a:srgbClr val="0F172A"/>
+                </a:solidFill>
+              </a:rPr>
+              <a:t>1.82x (Base 2.24x provides 23% safety buffer above break-even).</a:t>
             </a:r>
           </a:p>
           <a:p>
@@ -8033,20 +8135,20 @@
               <a:spcAft>
                 <a:spcPts val="400"/>
               </a:spcAft>
-              <a:defRPr sz="1000" b="1">
+              <a:defRPr sz="950" b="1">
                 <a:solidFill>
                   <a:srgbClr val="4338CA"/>
                 </a:solidFill>
               </a:defRPr>
             </a:pPr>
             <a:r>
-              <a:t>VOLUME ALLOCATION SENSITIVITY</a:t>
+              <a:t>CONTRIBUTION SENSITIVITY SCENARIOS</a:t>
             </a:r>
           </a:p>
           <a:p>
             <a:pPr>
               <a:spcAft>
-                <a:spcPts val="300"/>
+                <a:spcPts val="200"/>
               </a:spcAft>
             </a:pPr>
             <a:r>
@@ -8055,7 +8157,7 @@
                   <a:srgbClr val="1E1B4B"/>
                 </a:solidFill>
               </a:rPr>
-              <a:t>Tech Heavy (40/40/20): </a:t>
+              <a:t>CPL Inflation ($34.00): </a:t>
             </a:r>
             <a:r>
               <a:rPr b="0" i="0" sz="800">
@@ -8063,13 +8165,13 @@
                   <a:srgbClr val="0F172A"/>
                 </a:solidFill>
               </a:rPr>
-              <a:t>CPL $30.80 | Paid: 503 | Net Rev: $398k | ROAS 2.35x</a:t>
+              <a:t>+$15.2k contribution remaining</a:t>
             </a:r>
           </a:p>
           <a:p>
             <a:pPr>
               <a:spcAft>
-                <a:spcPts val="300"/>
+                <a:spcPts val="200"/>
               </a:spcAft>
             </a:pPr>
             <a:r>
@@ -8078,7 +8180,7 @@
                   <a:srgbClr val="1E1B4B"/>
                 </a:solidFill>
               </a:rPr>
-              <a:t>Balanced Base (30/45/25): </a:t>
+              <a:t>CPL Stress ($36.00): </a:t>
             </a:r>
             <a:r>
               <a:rPr b="0" i="0" sz="800">
@@ -8086,13 +8188,13 @@
                   <a:srgbClr val="0F172A"/>
                 </a:solidFill>
               </a:rPr>
-              <a:t>CPL $29.85 | Paid: 473 | Net Rev: $368k | ROAS 2.24x</a:t>
+              <a:t>+$4.2k contribution near break-even</a:t>
             </a:r>
           </a:p>
           <a:p>
             <a:pPr>
               <a:spcAft>
-                <a:spcPts val="300"/>
+                <a:spcPts val="200"/>
               </a:spcAft>
             </a:pPr>
             <a:r>
@@ -8101,7 +8203,7 @@
                   <a:srgbClr val="1E1B4B"/>
                 </a:solidFill>
               </a:rPr>
-              <a:t>Heartland Heavy (20/45/35): </a:t>
+              <a:t>Round 1 Show (64.8%): </a:t>
             </a:r>
             <a:r>
               <a:rPr b="0" i="0" sz="800">
@@ -8109,7 +8211,53 @@
                   <a:srgbClr val="0F172A"/>
                 </a:solidFill>
               </a:rPr>
-              <a:t>CPL $28.65 | Paid: 434 | Net Rev: $329k | ROAS 2.09x</a:t>
+              <a:t>+$20.4k contribution maintained</a:t>
+            </a:r>
+          </a:p>
+          <a:p>
+            <a:pPr>
+              <a:spcAft>
+                <a:spcPts val="200"/>
+              </a:spcAft>
+            </a:pPr>
+            <a:r>
+              <a:rPr b="1" i="0" sz="800">
+                <a:solidFill>
+                  <a:srgbClr val="1E1B4B"/>
+                </a:solidFill>
+              </a:rPr>
+              <a:t>Combined Headwind: </a:t>
+            </a:r>
+            <a:r>
+              <a:rPr b="0" i="0" sz="800">
+                <a:solidFill>
+                  <a:srgbClr val="0F172A"/>
+                </a:solidFill>
+              </a:rPr>
+              <a:t>-$2.4k deficit (CPL $34 + Show 64.8%)</a:t>
+            </a:r>
+          </a:p>
+          <a:p>
+            <a:pPr>
+              <a:spcAft>
+                <a:spcPts val="200"/>
+              </a:spcAft>
+            </a:pPr>
+            <a:r>
+              <a:rPr b="1" i="0" sz="800">
+                <a:solidFill>
+                  <a:srgbClr val="1E1B4B"/>
+                </a:solidFill>
+              </a:rPr>
+              <a:t>Severe Q4 CPM Surge: </a:t>
+            </a:r>
+            <a:r>
+              <a:rPr b="0" i="0" sz="800">
+                <a:solidFill>
+                  <a:srgbClr val="0F172A"/>
+                </a:solidFill>
+              </a:rPr>
+              <a:t>-$27.7k deficit (CPL $41.79 / +40%)</a:t>
             </a:r>
           </a:p>
         </p:txBody>
@@ -8197,7 +8345,7 @@
               </a:defRPr>
             </a:pPr>
             <a:r>
-              <a:t>5. Pillar 2: Meta CAPI &amp; Monotonic Expected Values P(Paid)*ARPU</a:t>
+              <a:t>5. Pillar 2: Meta CAPI v21.0 &amp; Monotonic Expected Values P(Paid)*ARPU</a:t>
             </a:r>
           </a:p>
         </p:txBody>
@@ -8271,31 +8419,31 @@
           <a:p>
             <a:pPr>
               <a:spcAft>
+                <a:spcPts val="600"/>
+              </a:spcAft>
+              <a:defRPr sz="1050" b="1">
+                <a:solidFill>
+                  <a:srgbClr val="4338CA"/>
+                </a:solidFill>
+              </a:defRPr>
+            </a:pPr>
+            <a:r>
+              <a:t>STRICTLY MONOTONIC CONVERSION VALUE CALIBRATION</a:t>
+            </a:r>
+          </a:p>
+          <a:p>
+            <a:pPr>
+              <a:spcAft>
                 <a:spcPts val="800"/>
               </a:spcAft>
-              <a:defRPr sz="1050" b="1">
-                <a:solidFill>
-                  <a:srgbClr val="4338CA"/>
+              <a:defRPr sz="850">
+                <a:solidFill>
+                  <a:srgbClr val="64748B"/>
                 </a:solidFill>
               </a:defRPr>
             </a:pPr>
             <a:r>
-              <a:t>STRICTLY MONOTONIC CONVERSION VALUE CALIBRATION</a:t>
-            </a:r>
-          </a:p>
-          <a:p>
-            <a:pPr>
-              <a:spcAft>
-                <a:spcPts val="1000"/>
-              </a:spcAft>
-              <a:defRPr sz="850">
-                <a:solidFill>
-                  <a:srgbClr val="64748B"/>
-                </a:solidFill>
-              </a:defRPr>
-            </a:pPr>
-            <a:r>
-              <a:t>Values represent mathematically expected downstream revenue P(Paid | Stage) x ARPU. Values strictly ascend down the funnel: Lead &lt; Schedule &lt; DemoAttended &lt; Purchase.</a:t>
+              <a:t>Values represent mathematically expected downstream revenue P(Paid | Stage) x ARPU, dispatched per event via real-time webhooks (Meta rejects requests if event_time &gt; 7 days old; no batch backlogs).</a:t>
             </a:r>
           </a:p>
         </p:txBody>
@@ -9015,7 +9163,7 @@
                   <a:srgbClr val="0F172A"/>
                 </a:solidFill>
               </a:rPr>
-              <a:t>Meta delivers optimal machine learning performance with &gt;50 events/week/ad-set. 'Schedule' generates ~3,723 events (~108/week/ad-set), comfortably exiting learning.</a:t>
+              <a:t>Meta delivers optimal machine learning with &gt;50 events/week/ad-set. 'Schedule' generates ~3,723 events (~108/week/ad-set), comfortably exiting learning.</a:t>
             </a:r>
           </a:p>
           <a:p>
@@ -9038,7 +9186,7 @@
                   <a:srgbClr val="0F172A"/>
                 </a:solidFill>
               </a:rPr>
-              <a:t>473 purchases over 60 days across 4 ad sets yields only ~3.5 purchases/week/ad-set—too sparse for Meta ML.</a:t>
+              <a:t>473 purchases over 60 days across 4 ad sets yields only ~3.5 purchases/week/ad-set—too sparse for Meta ML. Optimizing for deeper events also raises CPL.</a:t>
             </a:r>
           </a:p>
           <a:p>
@@ -9053,7 +9201,7 @@
                   <a:srgbClr val="1E1B4B"/>
                 </a:solidFill>
               </a:rPr>
-              <a:t>Value Signals: </a:t>
+              <a:t>Value Signals for Target ROAS: </a:t>
             </a:r>
             <a:r>
               <a:rPr b="0" i="0" sz="850">
@@ -9061,7 +9209,7 @@
                   <a:srgbClr val="0F172A"/>
                 </a:solidFill>
               </a:rPr>
-              <a:t>'DemoAttended' and 'Purchase' stream via CAPI as offline conversion value signals to guide Target ROAS / Value-Based Bidding.</a:t>
+              <a:t>'DemoAttended' and 'Purchase' stream via CAPI v21.0 as offline conversion value signals to guide Target ROAS / Value-Based Bidding.</a:t>
             </a:r>
           </a:p>
           <a:p>
@@ -9076,7 +9224,7 @@
                   <a:srgbClr val="1E1B4B"/>
                 </a:solidFill>
               </a:rPr>
-              <a:t>COPPA Privacy Guard: </a:t>
+              <a:t>Privacy &amp; COPPA Protection: </a:t>
             </a:r>
             <a:r>
               <a:rPr b="0" i="0" sz="850">
@@ -9084,7 +9232,7 @@
                   <a:srgbClr val="0F172A"/>
                 </a:solidFill>
               </a:rPr>
-              <a:t>Zero minor data sent to Meta. Only SHA-256 hashed parent contact records (email, phone, state, zip) transmitted.</a:t>
+              <a:t>Zero child data sent to Meta. Only SHA-256 hashed parent contact records (email, phone, state, zip) plus fbclid/fbc, fbp, client IP, and UA transmitted for deduplication.</a:t>
             </a:r>
           </a:p>
         </p:txBody>
@@ -9172,7 +9320,7 @@
               </a:defRPr>
             </a:pPr>
             <a:r>
-              <a:t>6. Dynamic Landing Page, SMS Verification &amp; Reminder Cadence</a:t>
+              <a:t>6. Dynamic Landing Page, Qualified Bridge &amp; Attendance Assurance</a:t>
             </a:r>
           </a:p>
         </p:txBody>
@@ -9192,7 +9340,7 @@
             <a:avLst/>
           </a:prstGeom>
           <a:solidFill>
-            <a:srgbClr val="FFFFFF"/>
+            <a:srgbClr val="EEF2FF"/>
           </a:solidFill>
           <a:ln w="19050">
             <a:solidFill>
@@ -9255,7 +9403,7 @@
               </a:defRPr>
             </a:pPr>
             <a:r>
-              <a:t>SELF-REPORTED LAPTOP READINESS</a:t>
+              <a:t>QUALIFIED LEAD BRIDGE</a:t>
             </a:r>
           </a:p>
           <a:p>
@@ -9270,7 +9418,7 @@
               </a:defRPr>
             </a:pPr>
             <a:r>
-              <a:t>Eliminates Device Penalty</a:t>
+              <a:t>Gating Mechanics</a:t>
             </a:r>
           </a:p>
           <a:p>
@@ -9282,17 +9430,25 @@
               </a:defRPr>
             </a:pPr>
             <a:r>
-              <a:t>Replaces mobile form penalty with self-reported field:</a:t>
+              <a:t>Qualified = OTP-verified phone + parent email + laptop access.</a:t>
             </a:r>
             <a:br/>
             <a:br/>
             <a:r>
-              <a:t>'Does your child have access to a laptop or desktop computer for the trial?'</a:t>
+              <a:t>• 90% Pass: 6,111 raw ($26.87 raw CPL)</a:t>
+            </a:r>
+            <a:br/>
+            <a:r>
+              <a:t>• 80% Pass: 6,875 raw ($23.88 raw CPL)</a:t>
+            </a:r>
+            <a:br/>
+            <a:r>
+              <a:t>• 70% Pass: 7,857 raw ($20.90 raw CPL)</a:t>
             </a:r>
             <a:br/>
             <a:br/>
             <a:r>
-              <a:t>Parents fill forms on smartphones while retaining home PC access.</a:t>
+              <a:t>Aligns with US Facebook education CPL benchmarks ($22.83 - $34.85).</a:t>
             </a:r>
           </a:p>
         </p:txBody>
@@ -9490,7 +9646,7 @@
               </a:defRPr>
             </a:pPr>
             <a:r>
-              <a:t>TCPA CONSENT CHECKBOX</a:t>
+              <a:t>VOUCHER A/B TEST TOGGLE</a:t>
             </a:r>
           </a:p>
           <a:p>
@@ -9505,7 +9661,7 @@
               </a:defRPr>
             </a:pPr>
             <a:r>
-              <a:t>Legal Telephony Compliance</a:t>
+              <a:t>Pricing Psychology</a:t>
             </a:r>
           </a:p>
           <a:p>
@@ -9517,12 +9673,12 @@
               </a:defRPr>
             </a:pPr>
             <a:r>
-              <a:t>Explicit opt-in checkbox consenting to reminder calls, SMS, and WhatsApp alerts.</a:t>
+              <a:t>A/B test $150 voucher ON vs OFF (Control) in Tier 1.</a:t>
             </a:r>
             <a:br/>
             <a:br/>
             <a:r>
-              <a:t>Clear disclosure that consent is not required for purchase, with opt-out mechanisms.</a:t>
+              <a:t>Ensures holiday discounting does not undercut premium brand perception among parents already paying Kumon-level rates.</a:t>
             </a:r>
           </a:p>
         </p:txBody>
@@ -9632,23 +9788,23 @@
               </a:defRPr>
             </a:pPr>
             <a:r>
-              <a:t>Confirmation screen establishes automated reminder schedule:</a:t>
+              <a:t>Recommends 3 slots within 48h (lag vs show rate link is correlational) + weekend slot toggle:</a:t>
             </a:r>
             <a:br/>
             <a:r>
-              <a:t>• T-24h: Calendar Invite via Email</a:t>
+              <a:t>• T-24h: Email invite &amp; prep guide</a:t>
             </a:r>
             <a:br/>
             <a:r>
-              <a:t>• T-2h: 1-Click Zoom Link via SMS</a:t>
+              <a:t>• T-2h: SMS 1-click Zoom link</a:t>
             </a:r>
             <a:br/>
             <a:r>
-              <a:t>• T-15m: Room Open Alert via WhatsApp</a:t>
+              <a:t>• T-15m: WhatsApp check-in</a:t>
             </a:r>
             <a:br/>
             <a:r>
-              <a:t>• Reschedule button eliminates ghosts.</a:t>
+              <a:t>• Reschedule link prevents ghosts.</a:t>
             </a:r>
           </a:p>
         </p:txBody>
@@ -9736,7 +9892,7 @@
               </a:defRPr>
             </a:pPr>
             <a:r>
-              <a:t>7. Operational Capacity: Demo Distribution by US Time Zone</a:t>
+              <a:t>7. Operational Capacity: Time Zone Distribution &amp; Peak Planning</a:t>
             </a:r>
           </a:p>
         </p:txBody>
@@ -9751,7 +9907,7 @@
         </p:nvGraphicFramePr>
         <p:xfrm>
           <a:off x="731520" y="1463040"/>
-          <a:ext cx="6858000" cy="2926080"/>
+          <a:ext cx="6858000" cy="3291840"/>
         </p:xfrm>
         <a:graphic>
           <a:graphicData uri="http://schemas.openxmlformats.org/drawingml/2006/table">
@@ -9766,7 +9922,7 @@
                 <a:gridCol w="1234440"/>
                 <a:gridCol w="1234440"/>
               </a:tblGrid>
-              <a:tr h="585216">
+              <a:tr h="548640">
                 <a:tc>
                   <a:txBody>
                     <a:bodyPr/>
@@ -9883,14 +10039,14 @@
                   </a:tcPr>
                 </a:tc>
               </a:tr>
-              <a:tr h="585216">
-                <a:tc>
-                  <a:txBody>
-                    <a:bodyPr/>
-                    <a:lstStyle/>
-                    <a:p>
-                      <a:pPr>
-                        <a:defRPr sz="850">
+              <a:tr h="548640">
+                <a:tc>
+                  <a:txBody>
+                    <a:bodyPr/>
+                    <a:lstStyle/>
+                    <a:p>
+                      <a:pPr>
+                        <a:defRPr sz="800">
                           <a:solidFill>
                             <a:srgbClr val="0F172A"/>
                           </a:solidFill>
@@ -9913,7 +10069,7 @@
                     <a:lstStyle/>
                     <a:p>
                       <a:pPr>
-                        <a:defRPr sz="850">
+                        <a:defRPr sz="800">
                           <a:solidFill>
                             <a:srgbClr val="0F172A"/>
                           </a:solidFill>
@@ -9936,7 +10092,7 @@
                     <a:lstStyle/>
                     <a:p>
                       <a:pPr>
-                        <a:defRPr sz="850">
+                        <a:defRPr sz="800">
                           <a:solidFill>
                             <a:srgbClr val="0F172A"/>
                           </a:solidFill>
@@ -9959,7 +10115,7 @@
                     <a:lstStyle/>
                     <a:p>
                       <a:pPr>
-                        <a:defRPr sz="850">
+                        <a:defRPr sz="800">
                           <a:solidFill>
                             <a:srgbClr val="0F172A"/>
                           </a:solidFill>
@@ -9982,7 +10138,7 @@
                     <a:lstStyle/>
                     <a:p>
                       <a:pPr>
-                        <a:defRPr sz="850">
+                        <a:defRPr sz="800">
                           <a:solidFill>
                             <a:srgbClr val="0F172A"/>
                           </a:solidFill>
@@ -10000,14 +10156,14 @@
                   </a:tcPr>
                 </a:tc>
               </a:tr>
-              <a:tr h="585216">
-                <a:tc>
-                  <a:txBody>
-                    <a:bodyPr/>
-                    <a:lstStyle/>
-                    <a:p>
-                      <a:pPr>
-                        <a:defRPr sz="850">
+              <a:tr h="548640">
+                <a:tc>
+                  <a:txBody>
+                    <a:bodyPr/>
+                    <a:lstStyle/>
+                    <a:p>
+                      <a:pPr>
+                        <a:defRPr sz="800">
                           <a:solidFill>
                             <a:srgbClr val="0F172A"/>
                           </a:solidFill>
@@ -10030,7 +10186,7 @@
                     <a:lstStyle/>
                     <a:p>
                       <a:pPr>
-                        <a:defRPr sz="850">
+                        <a:defRPr sz="800">
                           <a:solidFill>
                             <a:srgbClr val="0F172A"/>
                           </a:solidFill>
@@ -10053,7 +10209,7 @@
                     <a:lstStyle/>
                     <a:p>
                       <a:pPr>
-                        <a:defRPr sz="850">
+                        <a:defRPr sz="800">
                           <a:solidFill>
                             <a:srgbClr val="0F172A"/>
                           </a:solidFill>
@@ -10076,7 +10232,7 @@
                     <a:lstStyle/>
                     <a:p>
                       <a:pPr>
-                        <a:defRPr sz="850">
+                        <a:defRPr sz="800">
                           <a:solidFill>
                             <a:srgbClr val="0F172A"/>
                           </a:solidFill>
@@ -10099,7 +10255,7 @@
                     <a:lstStyle/>
                     <a:p>
                       <a:pPr>
-                        <a:defRPr sz="850">
+                        <a:defRPr sz="800">
                           <a:solidFill>
                             <a:srgbClr val="0F172A"/>
                           </a:solidFill>
@@ -10117,14 +10273,14 @@
                   </a:tcPr>
                 </a:tc>
               </a:tr>
-              <a:tr h="585216">
-                <a:tc>
-                  <a:txBody>
-                    <a:bodyPr/>
-                    <a:lstStyle/>
-                    <a:p>
-                      <a:pPr>
-                        <a:defRPr sz="850">
+              <a:tr h="548640">
+                <a:tc>
+                  <a:txBody>
+                    <a:bodyPr/>
+                    <a:lstStyle/>
+                    <a:p>
+                      <a:pPr>
+                        <a:defRPr sz="800">
                           <a:solidFill>
                             <a:srgbClr val="0F172A"/>
                           </a:solidFill>
@@ -10147,7 +10303,7 @@
                     <a:lstStyle/>
                     <a:p>
                       <a:pPr>
-                        <a:defRPr sz="850">
+                        <a:defRPr sz="800">
                           <a:solidFill>
                             <a:srgbClr val="0F172A"/>
                           </a:solidFill>
@@ -10170,7 +10326,7 @@
                     <a:lstStyle/>
                     <a:p>
                       <a:pPr>
-                        <a:defRPr sz="850">
+                        <a:defRPr sz="800">
                           <a:solidFill>
                             <a:srgbClr val="0F172A"/>
                           </a:solidFill>
@@ -10193,7 +10349,7 @@
                     <a:lstStyle/>
                     <a:p>
                       <a:pPr>
-                        <a:defRPr sz="850">
+                        <a:defRPr sz="800">
                           <a:solidFill>
                             <a:srgbClr val="0F172A"/>
                           </a:solidFill>
@@ -10216,7 +10372,7 @@
                     <a:lstStyle/>
                     <a:p>
                       <a:pPr>
-                        <a:defRPr sz="850">
+                        <a:defRPr sz="800">
                           <a:solidFill>
                             <a:srgbClr val="0F172A"/>
                           </a:solidFill>
@@ -10234,21 +10390,21 @@
                   </a:tcPr>
                 </a:tc>
               </a:tr>
-              <a:tr h="585216">
-                <a:tc>
-                  <a:txBody>
-                    <a:bodyPr/>
-                    <a:lstStyle/>
-                    <a:p>
-                      <a:pPr>
-                        <a:defRPr sz="850" b="1">
+              <a:tr h="548640">
+                <a:tc>
+                  <a:txBody>
+                    <a:bodyPr/>
+                    <a:lstStyle/>
+                    <a:p>
+                      <a:pPr>
+                        <a:defRPr sz="800" b="1">
                           <a:solidFill>
                             <a:srgbClr val="1E1B4B"/>
                           </a:solidFill>
                         </a:defRPr>
                       </a:pPr>
                       <a:r>
-                        <a:t>TOTAL DEDICATED POD</a:t>
+                        <a:t>BASE EVENING POD</a:t>
                       </a:r>
                     </a:p>
                   </a:txBody>
@@ -10264,7 +10420,7 @@
                     <a:lstStyle/>
                     <a:p>
                       <a:pPr>
-                        <a:defRPr sz="850" b="1">
+                        <a:defRPr sz="800" b="1">
                           <a:solidFill>
                             <a:srgbClr val="1E1B4B"/>
                           </a:solidFill>
@@ -10287,7 +10443,7 @@
                     <a:lstStyle/>
                     <a:p>
                       <a:pPr>
-                        <a:defRPr sz="850" b="1">
+                        <a:defRPr sz="800" b="1">
                           <a:solidFill>
                             <a:srgbClr val="1E1B4B"/>
                           </a:solidFill>
@@ -10310,14 +10466,14 @@
                     <a:lstStyle/>
                     <a:p>
                       <a:pPr>
-                        <a:defRPr sz="850" b="1">
+                        <a:defRPr sz="800" b="1">
                           <a:solidFill>
                             <a:srgbClr val="1E1B4B"/>
                           </a:solidFill>
                         </a:defRPr>
                       </a:pPr>
                       <a:r>
-                        <a:t>School-day Evenings</a:t>
+                        <a:t>46.5 demo-hours</a:t>
                       </a:r>
                     </a:p>
                   </a:txBody>
@@ -10333,20 +10489,137 @@
                     <a:lstStyle/>
                     <a:p>
                       <a:pPr>
-                        <a:defRPr sz="850" b="1">
+                        <a:defRPr sz="800" b="1">
                           <a:solidFill>
                             <a:srgbClr val="1E1B4B"/>
                           </a:solidFill>
                         </a:defRPr>
                       </a:pPr>
                       <a:r>
-                        <a:t>16 Mentors</a:t>
+                        <a:t>16 Mentors (73% util)</a:t>
                       </a:r>
                     </a:p>
                   </a:txBody>
                   <a:tcPr>
                     <a:solidFill>
                       <a:srgbClr val="EEF2FF"/>
+                    </a:solidFill>
+                  </a:tcPr>
+                </a:tc>
+              </a:tr>
+              <a:tr h="548640">
+                <a:tc>
+                  <a:txBody>
+                    <a:bodyPr/>
+                    <a:lstStyle/>
+                    <a:p>
+                      <a:pPr>
+                        <a:defRPr sz="800" b="1">
+                          <a:solidFill>
+                            <a:srgbClr val="1E1B4B"/>
+                          </a:solidFill>
+                        </a:defRPr>
+                      </a:pPr>
+                      <a:r>
+                        <a:t>PEAK LOAD (1.6x Surge)</a:t>
+                      </a:r>
+                    </a:p>
+                  </a:txBody>
+                  <a:tcPr>
+                    <a:solidFill>
+                      <a:srgbClr val="FEF2F2"/>
+                    </a:solidFill>
+                  </a:tcPr>
+                </a:tc>
+                <a:tc>
+                  <a:txBody>
+                    <a:bodyPr/>
+                    <a:lstStyle/>
+                    <a:p>
+                      <a:pPr>
+                        <a:defRPr sz="800" b="1">
+                          <a:solidFill>
+                            <a:srgbClr val="1E1B4B"/>
+                          </a:solidFill>
+                        </a:defRPr>
+                      </a:pPr>
+                      <a:r>
+                        <a:t>Weekend Peak</a:t>
+                      </a:r>
+                    </a:p>
+                  </a:txBody>
+                  <a:tcPr>
+                    <a:solidFill>
+                      <a:srgbClr val="FEF2F2"/>
+                    </a:solidFill>
+                  </a:tcPr>
+                </a:tc>
+                <a:tc>
+                  <a:txBody>
+                    <a:bodyPr/>
+                    <a:lstStyle/>
+                    <a:p>
+                      <a:pPr>
+                        <a:defRPr sz="800" b="1">
+                          <a:solidFill>
+                            <a:srgbClr val="1E1B4B"/>
+                          </a:solidFill>
+                        </a:defRPr>
+                      </a:pPr>
+                      <a:r>
+                        <a:t>~99 Demos/Day</a:t>
+                      </a:r>
+                    </a:p>
+                  </a:txBody>
+                  <a:tcPr>
+                    <a:solidFill>
+                      <a:srgbClr val="FEF2F2"/>
+                    </a:solidFill>
+                  </a:tcPr>
+                </a:tc>
+                <a:tc>
+                  <a:txBody>
+                    <a:bodyPr/>
+                    <a:lstStyle/>
+                    <a:p>
+                      <a:pPr>
+                        <a:defRPr sz="800" b="1">
+                          <a:solidFill>
+                            <a:srgbClr val="1E1B4B"/>
+                          </a:solidFill>
+                        </a:defRPr>
+                      </a:pPr>
+                      <a:r>
+                        <a:t>74.4 demo-hours</a:t>
+                      </a:r>
+                    </a:p>
+                  </a:txBody>
+                  <a:tcPr>
+                    <a:solidFill>
+                      <a:srgbClr val="FEF2F2"/>
+                    </a:solidFill>
+                  </a:tcPr>
+                </a:tc>
+                <a:tc>
+                  <a:txBody>
+                    <a:bodyPr/>
+                    <a:lstStyle/>
+                    <a:p>
+                      <a:pPr>
+                        <a:defRPr sz="800" b="1">
+                          <a:solidFill>
+                            <a:srgbClr val="1E1B4B"/>
+                          </a:solidFill>
+                        </a:defRPr>
+                      </a:pPr>
+                      <a:r>
+                        <a:t>&gt;100% (Mitigated)</a:t>
+                      </a:r>
+                    </a:p>
+                  </a:txBody>
+                  <a:tcPr>
+                    <a:solidFill>
+                      <a:srgbClr val="FEF2F2"/>
                     </a:solidFill>
                   </a:tcPr>
                 </a:tc>
@@ -10433,7 +10706,7 @@
               </a:defRPr>
             </a:pPr>
             <a:r>
-              <a:t>SALES COUNSELOR ROSTER &amp; LOGISTICS</a:t>
+              <a:t>CAPACITY MATH &amp; PEAK SURGE MITIGATION</a:t>
             </a:r>
           </a:p>
           <a:p>
@@ -10448,7 +10721,7 @@
                   <a:srgbClr val="1E1B4B"/>
                 </a:solidFill>
               </a:rPr>
-              <a:t>Daily Volume: </a:t>
+              <a:t>Average Daily Load: </a:t>
             </a:r>
             <a:r>
               <a:rPr b="0" i="0" sz="850">
@@ -10456,7 +10729,7 @@
                   <a:srgbClr val="0F172A"/>
                 </a:solidFill>
               </a:rPr>
-              <a:t>3,723 demos over 60 days requires conducting ~62 live 45-minute sessions daily.</a:t>
+              <a:t>3,723 demos over 60 days = ~62 demos/day (46.5 demo-hours needed).</a:t>
             </a:r>
           </a:p>
           <a:p>
@@ -10471,7 +10744,7 @@
                   <a:srgbClr val="1E1B4B"/>
                 </a:solidFill>
               </a:rPr>
-              <a:t>Capacity Math: </a:t>
+              <a:t>Base Mentor Roster: </a:t>
             </a:r>
             <a:r>
               <a:rPr b="0" i="0" sz="850">
@@ -10479,7 +10752,7 @@
                   <a:srgbClr val="0F172A"/>
                 </a:solidFill>
               </a:rPr>
-              <a:t>At 4 demos per mentor per shift, 62 demos requires 15.5 educators. A 16-mentor roster provides full coverage with a 15% surge buffer.</a:t>
+              <a:t>16 full-time mentors working 4-hour evening shifts provide 64 mentor-hours (73% base utilization).</a:t>
             </a:r>
           </a:p>
           <a:p>
@@ -10494,7 +10767,7 @@
                   <a:srgbClr val="1E1B4B"/>
                 </a:solidFill>
               </a:rPr>
-              <a:t>Timezone Shift Routing: </a:t>
+              <a:t>Peak Surge Risk (1.6x): </a:t>
             </a:r>
             <a:r>
               <a:rPr b="0" i="0" sz="850">
@@ -10502,7 +10775,7 @@
                   <a:srgbClr val="0F172A"/>
                 </a:solidFill>
               </a:rPr>
-              <a:t>Leads are routed dynamically based on parent phone area code and zip code to counselors in their matching timezone pod.</a:t>
+              <a:t>Weekend and after-school peaks surge demand to ~74.4 hours, exceeding 100% capacity of the evening pod.</a:t>
             </a:r>
           </a:p>
           <a:p>
@@ -10517,7 +10790,7 @@
                   <a:srgbClr val="1E1B4B"/>
                 </a:solidFill>
               </a:rPr>
-              <a:t>Weekend Morning Surge: </a:t>
+              <a:t>Mitigation Plan: </a:t>
             </a:r>
             <a:r>
               <a:rPr b="0" i="0" sz="850">
@@ -10525,7 +10798,7 @@
                   <a:srgbClr val="0F172A"/>
                 </a:solidFill>
               </a:rPr>
-              <a:t>Saturdays and Sundays feature 10:00 AM - 2:00 PM family slots to capture high-converting weekend demand.</a:t>
+              <a:t>Open Saturday/Sunday daytime blocks (10 AM - 3 PM) and maintain an on-call pool of 6 flex mentors managed by the US Shift Lead.</a:t>
             </a:r>
           </a:p>
         </p:txBody>

</xml_diff>

<commit_message>
docs: update memo and deck with Tier 3 contribution trade-off and refine canvas title
</commit_message>
<xml_diff>
--- a/deliverables/BrightCHAMPS_USA_Q4_Strategy_Deck.pptx
+++ b/deliverables/BrightCHAMPS_USA_Q4_Strategy_Deck.pptx
@@ -6986,11 +6986,11 @@
             </a:r>
             <a:br/>
             <a:r>
+              <a:t>• Tier 3 Contribution Trade-Off: Tier 3 ROAS is 1.40x vs 1.82x break-even (-$7.6k contribution loss); included to hold $30 CPL ceiling. Dropping it lifts blended CPL to $31.80 ($131.2k spend / 4,125 leads) but improves contribution by +$7.6k (Tier 1 &amp; 2 ROAS = 2.45x). Trimming it is our first reallocation lever.</a:t>
+            </a:r>
+            <a:br/>
+            <a:r>
               <a:t>• Monthly Pacing: November (2,500 leads @ $30.80 CPL = $77k; 50% Thanksgiving pause) | December (3,000 leads @ $29.06 CPL = $87,175).</a:t>
-            </a:r>
-            <a:br/>
-            <a:r>
-              <a:t>• Contingency Rule: If weekly blended CPL &gt; $33, shift budget to Tier 2/3 suburban zips and referral channels before cutting volume.</a:t>
             </a:r>
           </a:p>
         </p:txBody>

</xml_diff>